<commit_message>
docs: rename "harness" -> "detector" / "detection pipeline" (professor feedback)
Per feedback that "harness" misleadingly connotes tool-calling/infrastructure,
rename the shared fixed apparatus across the proposal (+recompiled PDF), the pitch
deck, DEVPLAN, AGENTS, and README. Uses "detector" (and "detection pipeline" for
the training-loop / slide-title sense) rather than the literal suggestion
"architecture", which would collide with the study's "architecture-matched tracks
/ architecture families (ViT vs CNN)" axis. Identifiers renamed consistently:
configs/harness.yaml -> configs/detector.yaml, sprint-3-harness -> sprint-3-detector,
test_harness_immutable -> test_detector_immutable. The detection head stays "head".

Deck edited via XML substitution on the 6 affected slides only (2,4,6,10,11,13);
verified byte-identical to the original in all other parts (98 parts, 8 images
intact) and schema-validated. Also gitignore Office ~$ lock files.
</commit_message>
<xml_diff>
--- a/xview3_jhu_pitch_v12.pptx
+++ b/xview3_jhu_pitch_v12.pptx
@@ -7561,7 +7561,7 @@
                             <a:srgbClr val="FFFFFF"/>
                           </a:solidFill>
                         </a:rPr>
-                        <a:t>Harness + eval owner</a:t>
+                        <a:t>Detector + eval owner</a:t>
                       </a:r>
                     </a:p>
                   </a:txBody>
@@ -7633,7 +7633,7 @@
                             <a:srgbClr val="1A2E50"/>
                           </a:solidFill>
                         </a:rPr>
-                        <a:t>Heatmap harness + frozen scorer; YOLO26 ref</a:t>
+                        <a:t>Heatmap detector + frozen scorer; YOLO26 ref</a:t>
                       </a:r>
                     </a:p>
                   </a:txBody>
@@ -8181,7 +8181,7 @@
           <a:p>
             <a:r>
               <a:rPr lang="en-US" dirty="0"/>
-              <a:t>5. Detection Harness</a:t>
+              <a:t>5. Detection Pipeline</a:t>
             </a:r>
           </a:p>
         </p:txBody>
@@ -8397,7 +8397,7 @@
             </a:r>
             <a:r>
               <a:rPr lang="en-US" dirty="0"/>
-              <a:t xml:space="preserve"> SatDINO ViT-B/16, an optical-satellite foundation model (DINO self-distillation on fMoW-RGB), downloaded and fine-tuned on xView3 through the same harness as every arm.</a:t>
+              <a:t xml:space="preserve"> SatDINO ViT-B/16, an optical-satellite foundation model (DINO self-distillation on fMoW-RGB), downloaded and fine-tuned on xView3 through the same detector as every arm.</a:t>
             </a:r>
           </a:p>
           <a:p>
@@ -9689,7 +9689,7 @@
           <a:p>
             <a:r>
               <a:rPr dirty="0"/>
-              <a:t>xView3 targets vessel detection in Sentinel-1 SAR, including dark vessels not broadcasting AIS. With labels scarce, we compare how well pretrained foundation backbones transfer under a fixed harness.</a:t>
+              <a:t>xView3 targets vessel detection in Sentinel-1 SAR, including dark vessels not broadcasting AIS. With labels scarce, we compare how well pretrained foundation backbones transfer under a fixed detector.</a:t>
             </a:r>
           </a:p>
         </p:txBody>
@@ -9982,7 +9982,7 @@
             <a:pPr lvl="1"/>
             <a:r>
               <a:rPr dirty="0"/>
-              <a:t>Jul 1-14: SARFish GRD subset + chipping + heatmap harness; YOLO26 reference (harness frozen)</a:t>
+              <a:t>Jul 1-14: SARFish GRD subset + chipping + heatmap detector; YOLO26 reference (detector frozen)</a:t>
             </a:r>
             <a:endParaRPr lang="en-US" dirty="0"/>
           </a:p>
@@ -10019,7 +10019,7 @@
             <a:pPr lvl="1"/>
             <a:r>
               <a:rPr lang="en-US" dirty="0"/>
-              <a:t>Two-person split: data/scorer owner vs. harness/eval owner</a:t>
+              <a:t>Two-person split: data/scorer owner vs. detector/eval owner</a:t>
             </a:r>
           </a:p>
         </p:txBody>
@@ -10413,7 +10413,7 @@
             </a:r>
             <a:r>
               <a:rPr lang="en-US" dirty="0"/>
-              <a:t xml:space="preserve"> Train on human-verified scenes, pseudo-label the noisy train scenes with high-confidence predictions (AI2 4th-place precedent; Zoph et al. 2020). Same harness; stands alone if pretraining underwhelms.</a:t>
+              <a:t xml:space="preserve"> Train on human-verified scenes, pseudo-label the noisy train scenes with high-confidence predictions (AI2 4th-place precedent; Zoph et al. 2020). Same detector; stands alone if pretraining underwhelms.</a:t>
             </a:r>
           </a:p>
           <a:p>

</xml_diff>